<commit_message>
S12: pivot 演習1 to spreadsheet fill-in worksheet
Replace "先に紙で設計" with a pre-built 情報設計 spreadsheet template
where the 考え方・判断基準 column is pre-filled by the instructor and
students fill the あなたの答え column while consulting Gemini. Adds a
Gemini相談ログ sheet to capture the consultation pattern.

Co-Authored-By: Claude Opus 4.7 (1M context) <noreply@anthropic.com>
Claude-Session: https://claude.ai/code/session_01MLnStsm4YQNeGye3rc2BGH
</commit_message>
<xml_diff>
--- a/lecture_pptx/out/s12/w12_01.pptx
+++ b/lecture_pptx/out/s12/w12_01.pptx
@@ -3148,7 +3148,7 @@
                 <a:ea typeface="Yu Gothic UI Semibold" pitchFamily="34" charset="-122"/>
                 <a:cs typeface="Yu Gothic UI Semibold" pitchFamily="34" charset="-120"/>
               </a:rPr>
-              <a:t>演習1 情報設計シートを作る (先に紙で設計)</a:t>
+              <a:t>演習1 設計テンプレを "考え方" と Geminiで埋める</a:t>
             </a:r>
             <a:endParaRPr lang="en-US" sz="2600" dirty="0"/>
           </a:p>
@@ -3276,7 +3276,7 @@
                 <a:ea typeface="Yu Gothic UI" pitchFamily="34" charset="-122"/>
                 <a:cs typeface="Yu Gothic UI" pitchFamily="34" charset="-120"/>
               </a:rPr>
-              <a:t>いきなりコードを書くと、AIが何を返しても「まあいいか」で通ってしまう。</a:t>
+              <a:t>いきなりGASを書くと、AIが何を返しても「まあいいか」で通ってしまう。</a:t>
             </a:r>
             <a:endParaRPr lang="en-US" sz="1400" dirty="0"/>
           </a:p>
@@ -3296,7 +3296,27 @@
                 <a:ea typeface="Yu Gothic UI" pitchFamily="34" charset="-122"/>
                 <a:cs typeface="Yu Gothic UI" pitchFamily="34" charset="-120"/>
               </a:rPr>
-              <a:t>先に「誰に・何を・どこから・どんな形で」を紙(スプシ)に落として、判断基準を固める。</a:t>
+              <a:t>あらかじめ用意された「情報設計テンプレ」スプシに、講師の解説と Gemini との相談で、</a:t>
+            </a:r>
+            <a:endParaRPr lang="en-US" sz="1400" dirty="0"/>
+          </a:p>
+          <a:p>
+            <a:pPr indent="0" marL="0">
+              <a:spcAft>
+                <a:spcPts val="400"/>
+              </a:spcAft>
+              <a:buNone/>
+            </a:pPr>
+            <a:r>
+              <a:rPr lang="en-US" sz="1400" dirty="0">
+                <a:solidFill>
+                  <a:srgbClr val="1A1A1A"/>
+                </a:solidFill>
+                <a:latin typeface="Yu Gothic UI" pitchFamily="34" charset="0"/>
+                <a:ea typeface="Yu Gothic UI" pitchFamily="34" charset="-122"/>
+                <a:cs typeface="Yu Gothic UI" pitchFamily="34" charset="-120"/>
+              </a:rPr>
+              <a:t>あなた自身の運用に合った項目を書き込んでいく。判断基準を固めるのが目的。</a:t>
             </a:r>
             <a:endParaRPr lang="en-US" sz="1400" dirty="0"/>
           </a:p>
@@ -3425,7 +3445,7 @@
                 <a:ea typeface="Yu Gothic UI" pitchFamily="34" charset="-122"/>
                 <a:cs typeface="Yu Gothic UI" pitchFamily="34" charset="-120"/>
               </a:rPr>
-              <a:t>Gemini に「お金初心者向け配信の情報設計シートを作って」と依頼</a:t>
+              <a:t>まず「考え方」列を先に読む(丸暗記ではなく理解する)</a:t>
             </a:r>
             <a:endParaRPr lang="en-US" sz="1400" dirty="0"/>
           </a:p>
@@ -3446,7 +3466,7 @@
                 <a:ea typeface="Yu Gothic UI" pitchFamily="34" charset="-122"/>
                 <a:cs typeface="Yu Gothic UI" pitchFamily="34" charset="-120"/>
               </a:rPr>
-              <a:t>ホワイトリストは "個別助言せず 一般情報だけ" を条件に選ぶ</a:t>
+              <a:t>テンプレ例をそのまま写さない、自分の運用に合わせて調整する</a:t>
             </a:r>
             <a:endParaRPr lang="en-US" sz="1400" dirty="0"/>
           </a:p>
@@ -3467,7 +3487,7 @@
                 <a:ea typeface="Yu Gothic UI" pitchFamily="34" charset="-122"/>
                 <a:cs typeface="Yu Gothic UI" pitchFamily="34" charset="-120"/>
               </a:rPr>
-              <a:t>「なぜこの設計にするか」の理由を各項目に添える</a:t>
+              <a:t>迷ったら Gemini に「私の状況で最適な選び方は?」と相談</a:t>
             </a:r>
             <a:endParaRPr lang="en-US" sz="1400" dirty="0"/>
           </a:p>
@@ -3488,7 +3508,7 @@
                 <a:ea typeface="Yu Gothic UI" pitchFamily="34" charset="-122"/>
                 <a:cs typeface="Yu Gothic UI" pitchFamily="34" charset="-120"/>
               </a:rPr>
-              <a:t>スプシの「情報設計」「情報源マスター」の2シートに保存</a:t>
+              <a:t>答えられない項目は "検討中" と書いてOK、後で埋めればよい</a:t>
             </a:r>
             <a:endParaRPr lang="en-US" sz="1400" dirty="0"/>
           </a:p>
@@ -3617,7 +3637,7 @@
                 <a:ea typeface="Yu Gothic UI" pitchFamily="34" charset="-122"/>
                 <a:cs typeface="Yu Gothic UI" pitchFamily="34" charset="-120"/>
               </a:rPr>
-              <a:t>ターゲット読者像(お金初心者)を1段落で</a:t>
+              <a:t>スプシ「情報設計」テンプレを開く(項目/考え方/あなたの答え/例 の4列)</a:t>
             </a:r>
             <a:endParaRPr lang="en-US" sz="1400" dirty="0"/>
           </a:p>
@@ -3638,7 +3658,7 @@
                 <a:ea typeface="Yu Gothic UI" pitchFamily="34" charset="-122"/>
                 <a:cs typeface="Yu Gothic UI" pitchFamily="34" charset="-120"/>
               </a:rPr>
-              <a:t>カテゴリを4つ確定(助成金/税金/株為替/お金の豆知識)</a:t>
+              <a:t>「考え方・判断基準」列を先に読み、なぜこの項目を決める必要があるかを理解</a:t>
             </a:r>
             <a:endParaRPr lang="en-US" sz="1400" dirty="0"/>
           </a:p>
@@ -3659,7 +3679,7 @@
                 <a:ea typeface="Yu Gothic UI" pitchFamily="34" charset="-122"/>
                 <a:cs typeface="Yu Gothic UI" pitchFamily="34" charset="-120"/>
               </a:rPr>
-              <a:t>情報源ホワイトリストを10サイト(国税庁/金融庁/中小企業庁/厚労省など)</a:t>
+              <a:t>各項目の「あなたの答え」列を、自分の運用に合わせて埋める</a:t>
             </a:r>
             <a:endParaRPr lang="en-US" sz="1400" dirty="0"/>
           </a:p>
@@ -3680,7 +3700,28 @@
                 <a:ea typeface="Yu Gothic UI" pitchFamily="34" charset="-122"/>
                 <a:cs typeface="Yu Gothic UI" pitchFamily="34" charset="-120"/>
               </a:rPr>
-              <a:t>配信フォーマット(タイトル20字/本文300字/絵文字+改行/出典URL必須)</a:t>
+              <a:t>迷ったところは Gemini に「私の場合はどう?」と相談しながら進める</a:t>
+            </a:r>
+            <a:endParaRPr lang="en-US" sz="1400" dirty="0"/>
+          </a:p>
+          <a:p>
+            <a:pPr marL="342900" indent="-342900">
+              <a:spcAft>
+                <a:spcPts val="400"/>
+              </a:spcAft>
+              <a:buSzPct val="100000"/>
+              <a:buChar char="●"/>
+            </a:pPr>
+            <a:r>
+              <a:rPr lang="en-US" sz="1400" dirty="0">
+                <a:solidFill>
+                  <a:srgbClr val="1A1A1A"/>
+                </a:solidFill>
+                <a:latin typeface="Yu Gothic UI" pitchFamily="34" charset="0"/>
+                <a:ea typeface="Yu Gothic UI" pitchFamily="34" charset="-122"/>
+                <a:cs typeface="Yu Gothic UI" pitchFamily="34" charset="-120"/>
+              </a:rPr>
+              <a:t>完成したスプシが 演習2 (GAS実装) の "仕様書" になる</a:t>
             </a:r>
             <a:endParaRPr lang="en-US" sz="1400" dirty="0"/>
           </a:p>
@@ -3771,7 +3812,7 @@
                 <a:ea typeface="Yu Gothic UI Semibold" pitchFamily="34" charset="-122"/>
                 <a:cs typeface="Yu Gothic UI Semibold" pitchFamily="34" charset="-120"/>
               </a:rPr>
-              <a:t>演習1 情報設計シートを作る (先に紙で設計) — 観点別チェック</a:t>
+              <a:t>演習1 設計テンプレを "考え方" と Geminiで埋める — 観点別チェック</a:t>
             </a:r>
             <a:endParaRPr lang="en-US" sz="2600" dirty="0"/>
           </a:p>
@@ -3935,7 +3976,7 @@
                 <a:ea typeface="Yu Gothic UI Semibold" pitchFamily="34" charset="-122"/>
                 <a:cs typeface="Yu Gothic UI Semibold" pitchFamily="34" charset="-120"/>
               </a:rPr>
-              <a:t>A. カテゴリ偏り</a:t>
+              <a:t>A. 理由の理解</a:t>
             </a:r>
             <a:endParaRPr lang="en-US" sz="1500" dirty="0"/>
           </a:p>
@@ -3988,7 +4029,7 @@
                 <a:ea typeface="Yu Gothic UI" pitchFamily="34" charset="-122"/>
                 <a:cs typeface="Yu Gothic UI" pitchFamily="34" charset="-120"/>
               </a:rPr>
-              <a:t>4カテゴリのバランスが取れているか(税だけに偏ってないか)</a:t>
+              <a:t>各項目の「なぜ必要か」を口頭で説明できるか</a:t>
             </a:r>
             <a:endParaRPr lang="en-US" sz="1300" dirty="0"/>
           </a:p>
@@ -4041,7 +4082,7 @@
                 <a:ea typeface="Yu Gothic UI" pitchFamily="34" charset="-122"/>
                 <a:cs typeface="Yu Gothic UI" pitchFamily="34" charset="-120"/>
               </a:rPr>
-              <a:t>過去1ヶ月のニュース10件で「どのカテゴリに何本あるか」を試算</a:t>
+              <a:t>「考え方」列を読んでから答えているか、丸暗記NG。理由を1文で言わせる</a:t>
             </a:r>
             <a:endParaRPr lang="en-US" sz="1300" dirty="0"/>
           </a:p>
@@ -4166,7 +4207,7 @@
                 <a:ea typeface="Yu Gothic UI Semibold" pitchFamily="34" charset="-122"/>
                 <a:cs typeface="Yu Gothic UI Semibold" pitchFamily="34" charset="-120"/>
               </a:rPr>
-              <a:t>B. 情報源の信頼性</a:t>
+              <a:t>B. 自分ごと化</a:t>
             </a:r>
             <a:endParaRPr lang="en-US" sz="1500" dirty="0"/>
           </a:p>
@@ -4219,7 +4260,7 @@
                 <a:ea typeface="Yu Gothic UI" pitchFamily="34" charset="-122"/>
                 <a:cs typeface="Yu Gothic UI" pitchFamily="34" charset="-120"/>
               </a:rPr>
-              <a:t>ホワイトリスト10サイトすべて "公的 or 準公的" と言えるか</a:t>
+              <a:t>テンプレ例をそのまま写すのではなく、自分の運用に合わせたか</a:t>
             </a:r>
             <a:endParaRPr lang="en-US" sz="1300" dirty="0"/>
           </a:p>
@@ -4272,7 +4313,7 @@
                 <a:ea typeface="Yu Gothic UI" pitchFamily="34" charset="-122"/>
                 <a:cs typeface="Yu Gothic UI" pitchFamily="34" charset="-120"/>
               </a:rPr>
-              <a:t>個人ブログ/アフィリエイトは全部除外、迷ったら金融庁で代替</a:t>
+              <a:t>「あなたの答え」列が"例"列と違う場所が3箇所以上あるか目視</a:t>
             </a:r>
             <a:endParaRPr lang="en-US" sz="1300" dirty="0"/>
           </a:p>
@@ -4397,7 +4438,7 @@
                 <a:ea typeface="Yu Gothic UI Semibold" pitchFamily="34" charset="-122"/>
                 <a:cs typeface="Yu Gothic UI Semibold" pitchFamily="34" charset="-120"/>
               </a:rPr>
-              <a:t>C. 配信フォーマットの再現性</a:t>
+              <a:t>C. AIとの共同作業</a:t>
             </a:r>
             <a:endParaRPr lang="en-US" sz="1500" dirty="0"/>
           </a:p>
@@ -4450,7 +4491,7 @@
                 <a:ea typeface="Yu Gothic UI" pitchFamily="34" charset="-122"/>
                 <a:cs typeface="Yu Gothic UI" pitchFamily="34" charset="-120"/>
               </a:rPr>
-              <a:t>AIが毎回同じ形で出せる粒度に定義できているか</a:t>
+              <a:t>迷ったところで Gemini に相談したか</a:t>
             </a:r>
             <a:endParaRPr lang="en-US" sz="1300" dirty="0"/>
           </a:p>
@@ -4503,7 +4544,7 @@
                 <a:ea typeface="Yu Gothic UI" pitchFamily="34" charset="-122"/>
                 <a:cs typeface="Yu Gothic UI" pitchFamily="34" charset="-120"/>
               </a:rPr>
-              <a:t>タイトル文字数/本文長/絵文字位置 まで指定する</a:t>
+              <a:t>相談ログ(質問→結論)をスプシ補足列 or 別シートに残させる</a:t>
             </a:r>
             <a:endParaRPr lang="en-US" sz="1300" dirty="0"/>
           </a:p>

</xml_diff>